<commit_message>
Hero: 'The property never leaves your custody'; add narcotics to LE scope
Property spans ammunition, narcotics, and seized assets in the buyer's
register. Ammunition remains the category lead; narcotics is stated as
capability in the law-enforcement block only.

Co-Authored-By: Claude Fable 5 <noreply@anthropic.com>
</commit_message>
<xml_diff>
--- a/deck/TWB_Vault_Capability_Brief.pptx
+++ b/deck/TWB_Vault_Capability_Brief.pptx
@@ -2014,32 +2014,56 @@
           <a:ln/>
         </p:spPr>
       </p:sp>
-      <p:sp>
-        <p:nvSpPr>
-          <p:cNvPr id="10" name="Text 8"/>
-          <p:cNvSpPr/>
-          <p:nvPr/>
-        </p:nvSpPr>
-        <p:spPr>
-          <a:xfrm>
-            <a:off x="868680" y="868680"/>
-            <a:ext cx="2926080" cy="365760"/>
-          </a:xfrm>
-          <a:prstGeom prst="rect">
-            <a:avLst/>
-          </a:prstGeom>
-          <a:noFill/>
-          <a:ln/>
-        </p:spPr>
-        <p:txBody>
-          <a:bodyPr wrap="square" lIns="0" tIns="0" rIns="0" bIns="0" rtlCol="0" anchor="ctr"/>
-          <a:lstStyle/>
-          <a:p>
-            <a:pPr indent="0" marL="0">
-              <a:buNone/>
-            </a:pPr>
-            <a:r>
-              <a:rPr lang="en-US" sz="2000" b="1" spc="-50" kern="0" dirty="0">
+      <p:pic>
+        <p:nvPicPr>
+          <p:cNvPr id="10" name="Image 0" descr="brand/twb-logo-black.png">    </p:cNvPr>
+          <p:cNvPicPr>
+            <a:picLocks noChangeAspect="1"/>
+          </p:cNvPicPr>
+          <p:nvPr/>
+        </p:nvPicPr>
+        <p:blipFill>
+          <a:blip r:embed="rId1"/>
+          <a:stretch>
+            <a:fillRect/>
+          </a:stretch>
+        </p:blipFill>
+        <p:spPr>
+          <a:xfrm>
+            <a:off x="868680" y="896112"/>
+            <a:ext cx="1303569" cy="201168"/>
+          </a:xfrm>
+          <a:prstGeom prst="rect">
+            <a:avLst/>
+          </a:prstGeom>
+        </p:spPr>
+      </p:pic>
+      <p:sp>
+        <p:nvSpPr>
+          <p:cNvPr id="11" name="Text 8"/>
+          <p:cNvSpPr/>
+          <p:nvPr/>
+        </p:nvSpPr>
+        <p:spPr>
+          <a:xfrm>
+            <a:off x="2232599" y="754111"/>
+            <a:ext cx="2194560" cy="402336"/>
+          </a:xfrm>
+          <a:prstGeom prst="rect">
+            <a:avLst/>
+          </a:prstGeom>
+          <a:noFill/>
+          <a:ln/>
+        </p:spPr>
+        <p:txBody>
+          <a:bodyPr wrap="square" lIns="0" tIns="0" rIns="0" bIns="0" rtlCol="0" anchor="b"/>
+          <a:lstStyle/>
+          <a:p>
+            <a:pPr algn="l" indent="0" marL="0">
+              <a:buNone/>
+            </a:pPr>
+            <a:r>
+              <a:rPr lang="en-US" sz="2218" b="1" spc="-40" kern="0" dirty="0">
                 <a:solidFill>
                   <a:srgbClr val="000000"/>
                 </a:solidFill>
@@ -2047,22 +2071,22 @@
                 <a:ea typeface="Helvetica Neue" pitchFamily="34" charset="-122"/>
                 <a:cs typeface="Helvetica Neue" pitchFamily="34" charset="-120"/>
               </a:rPr>
-              <a:t>TWB Designs</a:t>
-            </a:r>
-            <a:endParaRPr lang="en-US" sz="2000" dirty="0"/>
-          </a:p>
-        </p:txBody>
-      </p:sp>
-      <p:sp>
-        <p:nvSpPr>
-          <p:cNvPr id="11" name="Text 9"/>
-          <p:cNvSpPr/>
-          <p:nvPr/>
-        </p:nvSpPr>
-        <p:spPr>
-          <a:xfrm>
-            <a:off x="2788920" y="914400"/>
-            <a:ext cx="2743200" cy="292608"/>
+              <a:t>Designs</a:t>
+            </a:r>
+            <a:endParaRPr lang="en-US" sz="2218" dirty="0"/>
+          </a:p>
+        </p:txBody>
+      </p:sp>
+      <p:sp>
+        <p:nvSpPr>
+          <p:cNvPr id="12" name="Text 9"/>
+          <p:cNvSpPr/>
+          <p:nvPr/>
+        </p:nvSpPr>
+        <p:spPr>
+          <a:xfrm>
+            <a:off x="3662290" y="914400"/>
+            <a:ext cx="1828800" cy="256032"/>
           </a:xfrm>
           <a:prstGeom prst="rect">
             <a:avLst/>
@@ -2094,7 +2118,7 @@
       </p:sp>
       <p:sp>
         <p:nvSpPr>
-          <p:cNvPr id="12" name="Text 10"/>
+          <p:cNvPr id="13" name="Text 10"/>
           <p:cNvSpPr/>
           <p:nvPr/>
         </p:nvSpPr>
@@ -2156,7 +2180,7 @@
       </p:sp>
       <p:sp>
         <p:nvSpPr>
-          <p:cNvPr id="13" name="Text 11"/>
+          <p:cNvPr id="14" name="Text 11"/>
           <p:cNvSpPr/>
           <p:nvPr/>
         </p:nvSpPr>
@@ -2198,7 +2222,7 @@
       </p:sp>
       <p:sp>
         <p:nvSpPr>
-          <p:cNvPr id="14" name="Text 12"/>
+          <p:cNvPr id="15" name="Text 12"/>
           <p:cNvSpPr/>
           <p:nvPr/>
         </p:nvSpPr>
@@ -2237,7 +2261,7 @@
       </p:sp>
       <p:sp>
         <p:nvSpPr>
-          <p:cNvPr id="15" name="Text 13"/>
+          <p:cNvPr id="16" name="Text 13"/>
           <p:cNvSpPr/>
           <p:nvPr/>
         </p:nvSpPr>
@@ -2276,7 +2300,7 @@
       </p:sp>
       <p:sp>
         <p:nvSpPr>
-          <p:cNvPr id="16" name="Text 14"/>
+          <p:cNvPr id="17" name="Text 14"/>
           <p:cNvSpPr/>
           <p:nvPr/>
         </p:nvSpPr>
@@ -2315,7 +2339,7 @@
       </p:sp>
       <p:sp>
         <p:nvSpPr>
-          <p:cNvPr id="17" name="Text 15"/>
+          <p:cNvPr id="18" name="Text 15"/>
           <p:cNvSpPr/>
           <p:nvPr/>
         </p:nvSpPr>
@@ -2354,7 +2378,7 @@
       </p:sp>
       <p:sp>
         <p:nvSpPr>
-          <p:cNvPr id="18" name="Text 16"/>
+          <p:cNvPr id="19" name="Text 16"/>
           <p:cNvSpPr/>
           <p:nvPr/>
         </p:nvSpPr>
@@ -2393,7 +2417,7 @@
       </p:sp>
       <p:sp>
         <p:nvSpPr>
-          <p:cNvPr id="19" name="Text 17"/>
+          <p:cNvPr id="20" name="Text 17"/>
           <p:cNvSpPr/>
           <p:nvPr/>
         </p:nvSpPr>
@@ -2432,7 +2456,7 @@
       </p:sp>
       <p:sp>
         <p:nvSpPr>
-          <p:cNvPr id="20" name="Text 18"/>
+          <p:cNvPr id="21" name="Text 18"/>
           <p:cNvSpPr/>
           <p:nvPr/>
         </p:nvSpPr>
@@ -2471,7 +2495,7 @@
       </p:sp>
       <p:sp>
         <p:nvSpPr>
-          <p:cNvPr id="21" name="Text 19"/>
+          <p:cNvPr id="22" name="Text 19"/>
           <p:cNvSpPr/>
           <p:nvPr/>
         </p:nvSpPr>

</xml_diff>